<commit_message>
Refine AI-generated presentation and report formatting
</commit_message>
<xml_diff>
--- a/Bank_Churn_Presentation.pptx
+++ b/Bank_Churn_Presentation.pptx
@@ -11,6 +11,8 @@
     <p:sldId id="259" r:id="rId10"/>
     <p:sldId id="260" r:id="rId11"/>
     <p:sldId id="261" r:id="rId12"/>
+    <p:sldId id="262" r:id="rId13"/>
+    <p:sldId id="263" r:id="rId14"/>
   </p:sldIdLst>
   <p:sldSz cx="9144000" cy="6858000" type="screen4x3"/>
   <p:notesSz cx="6858000" cy="9144000"/>
@@ -3100,7 +3102,7 @@
             <a:spLocks noGrp="1"/>
           </p:cNvSpPr>
           <p:nvPr>
-            <p:ph type="title"/>
+            <p:ph type="ctrTitle"/>
           </p:nvPr>
         </p:nvSpPr>
         <p:spPr/>
@@ -3116,29 +3118,21 @@
       </p:sp>
       <p:sp>
         <p:nvSpPr>
-          <p:cNvPr id="3" name="Content Placeholder 2"/>
-          <p:cNvSpPr>
-            <a:spLocks noGrp="1"/>
-          </p:cNvSpPr>
-          <p:nvPr>
-            <p:ph idx="1"/>
-          </p:nvPr>
-        </p:nvSpPr>
-        <p:spPr/>
-        <p:txBody>
-          <a:bodyPr/>
-          <a:lstStyle/>
-          <a:p>
-            <a:r>
-              <a:t>Machine learning solution to predict customer churn for a bank.</a:t>
-            </a:r>
-          </a:p>
-          <a:p>
-            <a:pPr>
-              <a:defRPr sz="1800"/>
-            </a:pPr>
-            <a:r>
-              <a:t>Includes model training, deployment, and an interactive Streamlit app.</a:t>
+          <p:cNvPr id="3" name="Subtitle 2"/>
+          <p:cNvSpPr>
+            <a:spLocks noGrp="1"/>
+          </p:cNvSpPr>
+          <p:nvPr>
+            <p:ph type="subTitle" idx="1"/>
+          </p:nvPr>
+        </p:nvSpPr>
+        <p:spPr/>
+        <p:txBody>
+          <a:bodyPr/>
+          <a:lstStyle/>
+          <a:p>
+            <a:r>
+              <a:t>AI-generated project presentation with a polished structure for business and technical audiences.</a:t>
             </a:r>
           </a:p>
         </p:txBody>
@@ -3177,7 +3171,7 @@
           <a:lstStyle/>
           <a:p>
             <a:r>
-              <a:t>Problem Statement</a:t>
+              <a:t>Project Overview</a:t>
             </a:r>
           </a:p>
         </p:txBody>
@@ -3196,17 +3190,28 @@
         <p:txBody>
           <a:bodyPr/>
           <a:lstStyle/>
-          <a:p>
-            <a:r>
-              <a:t>Customer churn reduces bank revenue and increases acquisition costs.</a:t>
-            </a:r>
-          </a:p>
           <a:p>
             <a:pPr>
               <a:defRPr sz="1800"/>
             </a:pPr>
             <a:r>
-              <a:t>Predict churn early to enable retention interventions.</a:t>
+              <a:t>Predict whether bank customers will churn using machine learning.</a:t>
+            </a:r>
+          </a:p>
+          <a:p>
+            <a:pPr>
+              <a:defRPr sz="1800"/>
+            </a:pPr>
+            <a:r>
+              <a:t>Use customer profile and financial behavior features.</a:t>
+            </a:r>
+          </a:p>
+          <a:p>
+            <a:pPr>
+              <a:defRPr sz="1800"/>
+            </a:pPr>
+            <a:r>
+              <a:t>Built with Python, scikit-learn, XGBoost, and Streamlit.</a:t>
             </a:r>
           </a:p>
         </p:txBody>
@@ -3245,7 +3250,7 @@
           <a:lstStyle/>
           <a:p>
             <a:r>
-              <a:t>Approach</a:t>
+              <a:t>Problem Statement</a:t>
             </a:r>
           </a:p>
         </p:txBody>
@@ -3264,17 +3269,28 @@
         <p:txBody>
           <a:bodyPr/>
           <a:lstStyle/>
-          <a:p>
-            <a:r>
-              <a:t>Data cleaning, categorical encoding, feature engineering.</a:t>
-            </a:r>
-          </a:p>
           <a:p>
             <a:pPr>
               <a:defRPr sz="1800"/>
             </a:pPr>
             <a:r>
-              <a:t>Created balance-per-product feature and scaled numerical inputs.</a:t>
+              <a:t>Customer churn causes lost revenue and higher acquisition costs.</a:t>
+            </a:r>
+          </a:p>
+          <a:p>
+            <a:pPr>
+              <a:defRPr sz="1800"/>
+            </a:pPr>
+            <a:r>
+              <a:t>Objective: identify at-risk customers early.</a:t>
+            </a:r>
+          </a:p>
+          <a:p>
+            <a:pPr>
+              <a:defRPr sz="1800"/>
+            </a:pPr>
+            <a:r>
+              <a:t>Enable retention actions with targeted interventions.</a:t>
             </a:r>
           </a:p>
         </p:txBody>
@@ -3313,7 +3329,7 @@
           <a:lstStyle/>
           <a:p>
             <a:r>
-              <a:t>Model</a:t>
+              <a:t>Data &amp; Feature Engineering</a:t>
             </a:r>
           </a:p>
         </p:txBody>
@@ -3332,17 +3348,28 @@
         <p:txBody>
           <a:bodyPr/>
           <a:lstStyle/>
-          <a:p>
-            <a:r>
-              <a:t>Ensemble Voting Classifier with SVM, Gradient Boosting, and XGBoost.</a:t>
-            </a:r>
-          </a:p>
           <a:p>
             <a:pPr>
               <a:defRPr sz="1800"/>
             </a:pPr>
             <a:r>
-              <a:t>Soft voting uses predicted probabilities for final decision.</a:t>
+              <a:t>Used demographic and account data such as age, balance, tenure.</a:t>
+            </a:r>
+          </a:p>
+          <a:p>
+            <a:pPr>
+              <a:defRPr sz="1800"/>
+            </a:pPr>
+            <a:r>
+              <a:t>One-hot encoded gender and country features.</a:t>
+            </a:r>
+          </a:p>
+          <a:p>
+            <a:pPr>
+              <a:defRPr sz="1800"/>
+            </a:pPr>
+            <a:r>
+              <a:t>Created `balance_per_product` to measure engagement.</a:t>
             </a:r>
           </a:p>
         </p:txBody>
@@ -3381,7 +3408,7 @@
           <a:lstStyle/>
           <a:p>
             <a:r>
-              <a:t>Deployment</a:t>
+              <a:t>Modeling Approach</a:t>
             </a:r>
           </a:p>
         </p:txBody>
@@ -3400,17 +3427,28 @@
         <p:txBody>
           <a:bodyPr/>
           <a:lstStyle/>
-          <a:p>
-            <a:r>
-              <a:t>Streamlit app in `app.py` for interactive churn prediction.</a:t>
-            </a:r>
-          </a:p>
           <a:p>
             <a:pPr>
               <a:defRPr sz="1800"/>
             </a:pPr>
             <a:r>
-              <a:t>User enters profile data and receives churn risk probability.</a:t>
+              <a:t>Combined SVM, Gradient Boosting, and XGBoost in a Voting Classifier.</a:t>
+            </a:r>
+          </a:p>
+          <a:p>
+            <a:pPr>
+              <a:defRPr sz="1800"/>
+            </a:pPr>
+            <a:r>
+              <a:t>Soft voting aggregates prediction probabilities for accuracy.</a:t>
+            </a:r>
+          </a:p>
+          <a:p>
+            <a:pPr>
+              <a:defRPr sz="1800"/>
+            </a:pPr>
+            <a:r>
+              <a:t>Trained on scaled features for consistent model input.</a:t>
             </a:r>
           </a:p>
         </p:txBody>
@@ -3449,7 +3487,7 @@
           <a:lstStyle/>
           <a:p>
             <a:r>
-              <a:t>Deliverables</a:t>
+              <a:t>Interactive Application</a:t>
             </a:r>
           </a:p>
         </p:txBody>
@@ -3468,17 +3506,186 @@
         <p:txBody>
           <a:bodyPr/>
           <a:lstStyle/>
-          <a:p>
-            <a:r>
-              <a:t>Report: `project_report.md`</a:t>
-            </a:r>
-          </a:p>
           <a:p>
             <a:pPr>
               <a:defRPr sz="1800"/>
             </a:pPr>
             <a:r>
-              <a:t>Presentation: `Bank_Churn_Presentation.pptx`</a:t>
+              <a:t>Streamlit app accepts customer details for real-time scoring.</a:t>
+            </a:r>
+          </a:p>
+          <a:p>
+            <a:pPr>
+              <a:defRPr sz="1800"/>
+            </a:pPr>
+            <a:r>
+              <a:t>Displays churn probability and risk insights.</a:t>
+            </a:r>
+          </a:p>
+          <a:p>
+            <a:pPr>
+              <a:defRPr sz="1800"/>
+            </a:pPr>
+            <a:r>
+              <a:t>Supports business decisions for customer retention.</a:t>
+            </a:r>
+          </a:p>
+        </p:txBody>
+      </p:sp>
+    </p:spTree>
+  </p:cSld>
+  <p:clrMapOvr>
+    <a:masterClrMapping/>
+  </p:clrMapOvr>
+</p:sld>
+</file>
+
+<file path=ppt/slides/slide7.xml><?xml version="1.0" encoding="utf-8"?>
+<p:sld xmlns:a="http://schemas.openxmlformats.org/drawingml/2006/main" xmlns:p="http://schemas.openxmlformats.org/presentationml/2006/main" xmlns:r="http://schemas.openxmlformats.org/officeDocument/2006/relationships">
+  <p:cSld>
+    <p:spTree>
+      <p:nvGrpSpPr>
+        <p:cNvPr id="1" name=""/>
+        <p:cNvGrpSpPr/>
+        <p:nvPr/>
+      </p:nvGrpSpPr>
+      <p:grpSpPr/>
+      <p:sp>
+        <p:nvSpPr>
+          <p:cNvPr id="2" name="Title 1"/>
+          <p:cNvSpPr>
+            <a:spLocks noGrp="1"/>
+          </p:cNvSpPr>
+          <p:nvPr>
+            <p:ph type="title"/>
+          </p:nvPr>
+        </p:nvSpPr>
+        <p:spPr/>
+        <p:txBody>
+          <a:bodyPr/>
+          <a:lstStyle/>
+          <a:p>
+            <a:r>
+              <a:t>Results &amp; Next Steps</a:t>
+            </a:r>
+          </a:p>
+        </p:txBody>
+      </p:sp>
+      <p:sp>
+        <p:nvSpPr>
+          <p:cNvPr id="3" name="Content Placeholder 2"/>
+          <p:cNvSpPr>
+            <a:spLocks noGrp="1"/>
+          </p:cNvSpPr>
+          <p:nvPr>
+            <p:ph idx="1"/>
+          </p:nvPr>
+        </p:nvSpPr>
+        <p:spPr/>
+        <p:txBody>
+          <a:bodyPr/>
+          <a:lstStyle/>
+          <a:p>
+            <a:pPr>
+              <a:defRPr sz="1800"/>
+            </a:pPr>
+            <a:r>
+              <a:t>Deliver a deployable model and easy-to-use prediction app.</a:t>
+            </a:r>
+          </a:p>
+          <a:p>
+            <a:pPr>
+              <a:defRPr sz="1800"/>
+            </a:pPr>
+            <a:r>
+              <a:t>Future work: hyperparameter tuning and richer features.</a:t>
+            </a:r>
+          </a:p>
+          <a:p>
+            <a:pPr>
+              <a:defRPr sz="1800"/>
+            </a:pPr>
+            <a:r>
+              <a:t>Expand deployment options and integrate customer feedback.</a:t>
+            </a:r>
+          </a:p>
+        </p:txBody>
+      </p:sp>
+    </p:spTree>
+  </p:cSld>
+  <p:clrMapOvr>
+    <a:masterClrMapping/>
+  </p:clrMapOvr>
+</p:sld>
+</file>
+
+<file path=ppt/slides/slide8.xml><?xml version="1.0" encoding="utf-8"?>
+<p:sld xmlns:a="http://schemas.openxmlformats.org/drawingml/2006/main" xmlns:p="http://schemas.openxmlformats.org/presentationml/2006/main" xmlns:r="http://schemas.openxmlformats.org/officeDocument/2006/relationships">
+  <p:cSld>
+    <p:spTree>
+      <p:nvGrpSpPr>
+        <p:cNvPr id="1" name=""/>
+        <p:cNvGrpSpPr/>
+        <p:nvPr/>
+      </p:nvGrpSpPr>
+      <p:grpSpPr/>
+      <p:sp>
+        <p:nvSpPr>
+          <p:cNvPr id="2" name="Title 1"/>
+          <p:cNvSpPr>
+            <a:spLocks noGrp="1"/>
+          </p:cNvSpPr>
+          <p:nvPr>
+            <p:ph type="title"/>
+          </p:nvPr>
+        </p:nvSpPr>
+        <p:spPr/>
+        <p:txBody>
+          <a:bodyPr/>
+          <a:lstStyle/>
+          <a:p>
+            <a:r>
+              <a:t>AI-Generated Deliverables</a:t>
+            </a:r>
+          </a:p>
+        </p:txBody>
+      </p:sp>
+      <p:sp>
+        <p:nvSpPr>
+          <p:cNvPr id="3" name="Content Placeholder 2"/>
+          <p:cNvSpPr>
+            <a:spLocks noGrp="1"/>
+          </p:cNvSpPr>
+          <p:nvPr>
+            <p:ph idx="1"/>
+          </p:nvPr>
+        </p:nvSpPr>
+        <p:spPr/>
+        <p:txBody>
+          <a:bodyPr/>
+          <a:lstStyle/>
+          <a:p>
+            <a:pPr>
+              <a:defRPr sz="1800"/>
+            </a:pPr>
+            <a:r>
+              <a:t>This presentation was generated automatically using a Python script.</a:t>
+            </a:r>
+          </a:p>
+          <a:p>
+            <a:pPr>
+              <a:defRPr sz="1800"/>
+            </a:pPr>
+            <a:r>
+              <a:t>It is designed to be clear, professional, and easy to present.</a:t>
+            </a:r>
+          </a:p>
+          <a:p>
+            <a:pPr>
+              <a:defRPr sz="1800"/>
+            </a:pPr>
+            <a:r>
+              <a:t>Regenerate or customize the slides by editing generate_deliverables.py.</a:t>
             </a:r>
           </a:p>
         </p:txBody>

</xml_diff>